<commit_message>
feat(presentation): embed full gitdiagram architecture diagram on slide 7
</commit_message>
<xml_diff>
--- a/PatentIQ_Final_Review_Presentation.pptx
+++ b/PatentIQ_Final_Review_Presentation.pptx
@@ -9965,7 +9965,7 @@
               </a:defRPr>
             </a:pPr>
             <a:r>
-              <a:t>System Architecture &amp; Real Dataflow Pipeline</a:t>
+              <a:t>System Architecture &amp; End-to-End Pipeline Dataflow</a:t>
             </a:r>
           </a:p>
         </p:txBody>
@@ -10023,14 +10023,14 @@
         </p:nvSpPr>
         <p:spPr>
           <a:xfrm>
-            <a:off x="731520" y="1645920"/>
-            <a:ext cx="2011680" cy="1005840"/>
+            <a:off x="731520" y="1417320"/>
+            <a:ext cx="10728655" cy="5074920"/>
           </a:xfrm>
           <a:prstGeom prst="roundRect">
             <a:avLst/>
           </a:prstGeom>
           <a:solidFill>
-            <a:srgbClr val="1C1C1C"/>
+            <a:srgbClr val="141414"/>
           </a:solidFill>
           <a:ln w="15240">
             <a:solidFill>
@@ -10053,81 +10053,6 @@
           </a:fontRef>
         </p:style>
         <p:txBody>
-          <a:bodyPr rtlCol="0" anchor="ctr" wrap="square"/>
-          <a:lstStyle/>
-          <a:p>
-            <a:pPr algn="ctr">
-              <a:defRPr sz="1200" b="1">
-                <a:solidFill>
-                  <a:srgbClr val="FFFFFF"/>
-                </a:solidFill>
-                <a:latin typeface="Segoe UI"/>
-              </a:defRPr>
-            </a:pPr>
-            <a:r>
-              <a:t>1. USER DISCLOSURE</a:t>
-            </a:r>
-          </a:p>
-          <a:p>
-            <a:pPr algn="ctr">
-              <a:spcBef>
-                <a:spcPts val="300"/>
-              </a:spcBef>
-              <a:defRPr sz="950">
-                <a:solidFill>
-                  <a:srgbClr val="AAAAAA"/>
-                </a:solidFill>
-                <a:latin typeface="Segoe UI"/>
-              </a:defRPr>
-            </a:pPr>
-            <a:r>
-              <a:t>DOCX / PDF / TXT Upload</a:t>
-            </a:r>
-            <a:br/>
-            <a:r>
-              <a:t>Metadata &amp; Domain</a:t>
-            </a:r>
-          </a:p>
-        </p:txBody>
-      </p:sp>
-      <p:sp>
-        <p:nvSpPr>
-          <p:cNvPr id="6" name="Right Arrow 5"/>
-          <p:cNvSpPr/>
-          <p:nvPr/>
-        </p:nvSpPr>
-        <p:spPr>
-          <a:xfrm>
-            <a:off x="2834640" y="2011680"/>
-            <a:ext cx="365760" cy="228600"/>
-          </a:xfrm>
-          <a:prstGeom prst="rightArrow">
-            <a:avLst/>
-          </a:prstGeom>
-          <a:solidFill>
-            <a:srgbClr val="787878"/>
-          </a:solidFill>
-          <a:ln>
-            <a:solidFill>
-              <a:srgbClr val="787878"/>
-            </a:solidFill>
-          </a:ln>
-        </p:spPr>
-        <p:style>
-          <a:lnRef idx="1">
-            <a:schemeClr val="accent1"/>
-          </a:lnRef>
-          <a:fillRef idx="3">
-            <a:schemeClr val="accent1"/>
-          </a:fillRef>
-          <a:effectRef idx="2">
-            <a:schemeClr val="accent1"/>
-          </a:effectRef>
-          <a:fontRef idx="minor">
-            <a:schemeClr val="lt1"/>
-          </a:fontRef>
-        </p:style>
-        <p:txBody>
           <a:bodyPr rtlCol="0" anchor="ctr"/>
           <a:lstStyle/>
           <a:p>
@@ -10135,1246 +10060,30 @@
           </a:p>
         </p:txBody>
       </p:sp>
-      <p:sp>
-        <p:nvSpPr>
-          <p:cNvPr id="7" name="Rounded Rectangle 6"/>
-          <p:cNvSpPr/>
-          <p:nvPr/>
-        </p:nvSpPr>
-        <p:spPr>
-          <a:xfrm>
-            <a:off x="3291840" y="1645920"/>
-            <a:ext cx="2286000" cy="1005840"/>
-          </a:xfrm>
-          <a:prstGeom prst="roundRect">
-            <a:avLst/>
-          </a:prstGeom>
-          <a:solidFill>
-            <a:srgbClr val="1C1C1C"/>
-          </a:solidFill>
-          <a:ln w="15240">
-            <a:solidFill>
-              <a:srgbClr val="373737"/>
-            </a:solidFill>
-          </a:ln>
-        </p:spPr>
-        <p:style>
-          <a:lnRef idx="1">
-            <a:schemeClr val="accent1"/>
-          </a:lnRef>
-          <a:fillRef idx="3">
-            <a:schemeClr val="accent1"/>
-          </a:fillRef>
-          <a:effectRef idx="2">
-            <a:schemeClr val="accent1"/>
-          </a:effectRef>
-          <a:fontRef idx="minor">
-            <a:schemeClr val="lt1"/>
-          </a:fontRef>
-        </p:style>
-        <p:txBody>
-          <a:bodyPr rtlCol="0" anchor="ctr" wrap="square"/>
-          <a:lstStyle/>
-          <a:p>
-            <a:pPr algn="ctr">
-              <a:defRPr sz="1200" b="1">
-                <a:solidFill>
-                  <a:srgbClr val="FFFFFF"/>
-                </a:solidFill>
-                <a:latin typeface="Segoe UI"/>
-              </a:defRPr>
-            </a:pPr>
-            <a:r>
-              <a:t>2. INGESTION &amp; CHUNKING</a:t>
-            </a:r>
-          </a:p>
-          <a:p>
-            <a:pPr algn="ctr">
-              <a:spcBef>
-                <a:spcPts val="300"/>
-              </a:spcBef>
-              <a:defRPr sz="950">
-                <a:solidFill>
-                  <a:srgbClr val="AAAAAA"/>
-                </a:solidFill>
-                <a:latin typeface="Segoe UI"/>
-              </a:defRPr>
-            </a:pPr>
-            <a:r>
-              <a:t>Section Parser (Claims/Desc)</a:t>
-            </a:r>
-            <a:br/>
-            <a:r>
-              <a:t>Sliding Window (500 chars)</a:t>
-            </a:r>
-          </a:p>
-        </p:txBody>
-      </p:sp>
-      <p:sp>
-        <p:nvSpPr>
-          <p:cNvPr id="8" name="Right Arrow 7"/>
-          <p:cNvSpPr/>
-          <p:nvPr/>
-        </p:nvSpPr>
-        <p:spPr>
-          <a:xfrm>
-            <a:off x="5669280" y="2011680"/>
-            <a:ext cx="365760" cy="228600"/>
-          </a:xfrm>
-          <a:prstGeom prst="rightArrow">
-            <a:avLst/>
-          </a:prstGeom>
-          <a:solidFill>
-            <a:srgbClr val="787878"/>
-          </a:solidFill>
-          <a:ln>
-            <a:solidFill>
-              <a:srgbClr val="787878"/>
-            </a:solidFill>
-          </a:ln>
-        </p:spPr>
-        <p:style>
-          <a:lnRef idx="1">
-            <a:schemeClr val="accent1"/>
-          </a:lnRef>
-          <a:fillRef idx="3">
-            <a:schemeClr val="accent1"/>
-          </a:fillRef>
-          <a:effectRef idx="2">
-            <a:schemeClr val="accent1"/>
-          </a:effectRef>
-          <a:fontRef idx="minor">
-            <a:schemeClr val="lt1"/>
-          </a:fontRef>
-        </p:style>
-        <p:txBody>
-          <a:bodyPr rtlCol="0" anchor="ctr"/>
-          <a:lstStyle/>
-          <a:p>
-            <a:pPr algn="ctr"/>
-          </a:p>
-        </p:txBody>
-      </p:sp>
-      <p:sp>
-        <p:nvSpPr>
-          <p:cNvPr id="9" name="Rounded Rectangle 8"/>
-          <p:cNvSpPr/>
-          <p:nvPr/>
-        </p:nvSpPr>
-        <p:spPr>
-          <a:xfrm>
-            <a:off x="6126480" y="1645920"/>
-            <a:ext cx="2377440" cy="1005840"/>
-          </a:xfrm>
-          <a:prstGeom prst="roundRect">
-            <a:avLst/>
-          </a:prstGeom>
-          <a:solidFill>
-            <a:srgbClr val="1C1C1C"/>
-          </a:solidFill>
-          <a:ln w="15240">
-            <a:solidFill>
-              <a:srgbClr val="373737"/>
-            </a:solidFill>
-          </a:ln>
-        </p:spPr>
-        <p:style>
-          <a:lnRef idx="1">
-            <a:schemeClr val="accent1"/>
-          </a:lnRef>
-          <a:fillRef idx="3">
-            <a:schemeClr val="accent1"/>
-          </a:fillRef>
-          <a:effectRef idx="2">
-            <a:schemeClr val="accent1"/>
-          </a:effectRef>
-          <a:fontRef idx="minor">
-            <a:schemeClr val="lt1"/>
-          </a:fontRef>
-        </p:style>
-        <p:txBody>
-          <a:bodyPr rtlCol="0" anchor="ctr" wrap="square"/>
-          <a:lstStyle/>
-          <a:p>
-            <a:pPr algn="ctr">
-              <a:defRPr sz="1200" b="1">
-                <a:solidFill>
-                  <a:srgbClr val="FFFFFF"/>
-                </a:solidFill>
-                <a:latin typeface="Segoe UI"/>
-              </a:defRPr>
-            </a:pPr>
-            <a:r>
-              <a:t>3. FEATURE EXTRACTION</a:t>
-            </a:r>
-          </a:p>
-          <a:p>
-            <a:pPr algn="ctr">
-              <a:spcBef>
-                <a:spcPts val="300"/>
-              </a:spcBef>
-              <a:defRPr sz="950">
-                <a:solidFill>
-                  <a:srgbClr val="AAAAAA"/>
-                </a:solidFill>
-                <a:latin typeface="Segoe UI"/>
-              </a:defRPr>
-            </a:pPr>
-            <a:r>
-              <a:t>AST &amp; NLP Rule Heuristics</a:t>
-            </a:r>
-            <a:br/>
-            <a:r>
-              <a:t>Predicate Normalization</a:t>
-            </a:r>
-          </a:p>
-        </p:txBody>
-      </p:sp>
-      <p:sp>
-        <p:nvSpPr>
-          <p:cNvPr id="10" name="Right Arrow 9"/>
-          <p:cNvSpPr/>
-          <p:nvPr/>
-        </p:nvSpPr>
-        <p:spPr>
-          <a:xfrm>
-            <a:off x="8595360" y="2011680"/>
-            <a:ext cx="365760" cy="228600"/>
-          </a:xfrm>
-          <a:prstGeom prst="rightArrow">
-            <a:avLst/>
-          </a:prstGeom>
-          <a:solidFill>
-            <a:srgbClr val="787878"/>
-          </a:solidFill>
-          <a:ln>
-            <a:solidFill>
-              <a:srgbClr val="787878"/>
-            </a:solidFill>
-          </a:ln>
-        </p:spPr>
-        <p:style>
-          <a:lnRef idx="1">
-            <a:schemeClr val="accent1"/>
-          </a:lnRef>
-          <a:fillRef idx="3">
-            <a:schemeClr val="accent1"/>
-          </a:fillRef>
-          <a:effectRef idx="2">
-            <a:schemeClr val="accent1"/>
-          </a:effectRef>
-          <a:fontRef idx="minor">
-            <a:schemeClr val="lt1"/>
-          </a:fontRef>
-        </p:style>
-        <p:txBody>
-          <a:bodyPr rtlCol="0" anchor="ctr"/>
-          <a:lstStyle/>
-          <a:p>
-            <a:pPr algn="ctr"/>
-          </a:p>
-        </p:txBody>
-      </p:sp>
-      <p:sp>
-        <p:nvSpPr>
-          <p:cNvPr id="11" name="Rounded Rectangle 10"/>
-          <p:cNvSpPr/>
-          <p:nvPr/>
-        </p:nvSpPr>
-        <p:spPr>
-          <a:xfrm>
-            <a:off x="9052560" y="1645920"/>
-            <a:ext cx="2377440" cy="1005840"/>
-          </a:xfrm>
-          <a:prstGeom prst="roundRect">
-            <a:avLst/>
-          </a:prstGeom>
-          <a:solidFill>
-            <a:srgbClr val="1C1C1C"/>
-          </a:solidFill>
-          <a:ln w="15240">
-            <a:solidFill>
-              <a:srgbClr val="373737"/>
-            </a:solidFill>
-          </a:ln>
-        </p:spPr>
-        <p:style>
-          <a:lnRef idx="1">
-            <a:schemeClr val="accent1"/>
-          </a:lnRef>
-          <a:fillRef idx="3">
-            <a:schemeClr val="accent1"/>
-          </a:fillRef>
-          <a:effectRef idx="2">
-            <a:schemeClr val="accent1"/>
-          </a:effectRef>
-          <a:fontRef idx="minor">
-            <a:schemeClr val="lt1"/>
-          </a:fontRef>
-        </p:style>
-        <p:txBody>
-          <a:bodyPr rtlCol="0" anchor="ctr" wrap="square"/>
-          <a:lstStyle/>
-          <a:p>
-            <a:pPr algn="ctr">
-              <a:defRPr sz="1200" b="1">
-                <a:solidFill>
-                  <a:srgbClr val="FFFFFF"/>
-                </a:solidFill>
-                <a:latin typeface="Segoe UI"/>
-              </a:defRPr>
-            </a:pPr>
-            <a:r>
-              <a:t>4. USPTO CORPUS INDEX</a:t>
-            </a:r>
-          </a:p>
-          <a:p>
-            <a:pPr algn="ctr">
-              <a:spcBef>
-                <a:spcPts val="300"/>
-              </a:spcBef>
-              <a:defRPr sz="950">
-                <a:solidFill>
-                  <a:srgbClr val="AAAAAA"/>
-                </a:solidFill>
-                <a:latin typeface="Segoe UI"/>
-              </a:defRPr>
-            </a:pPr>
-            <a:r>
-              <a:t>100-Patent Pilot (500 chunks)</a:t>
-            </a:r>
-            <a:br/>
-            <a:r>
-              <a:t>BM25 + Qdrant Vector DB</a:t>
-            </a:r>
-          </a:p>
-        </p:txBody>
-      </p:sp>
-      <p:sp>
-        <p:nvSpPr>
-          <p:cNvPr id="12" name="Rounded Rectangle 11"/>
-          <p:cNvSpPr/>
-          <p:nvPr/>
-        </p:nvSpPr>
-        <p:spPr>
-          <a:xfrm>
-            <a:off x="731520" y="3108960"/>
-            <a:ext cx="2377440" cy="1005840"/>
-          </a:xfrm>
-          <a:prstGeom prst="roundRect">
-            <a:avLst/>
-          </a:prstGeom>
-          <a:solidFill>
-            <a:srgbClr val="1C1C1C"/>
-          </a:solidFill>
-          <a:ln w="15240">
-            <a:solidFill>
-              <a:srgbClr val="373737"/>
-            </a:solidFill>
-          </a:ln>
-        </p:spPr>
-        <p:style>
-          <a:lnRef idx="1">
-            <a:schemeClr val="accent1"/>
-          </a:lnRef>
-          <a:fillRef idx="3">
-            <a:schemeClr val="accent1"/>
-          </a:fillRef>
-          <a:effectRef idx="2">
-            <a:schemeClr val="accent1"/>
-          </a:effectRef>
-          <a:fontRef idx="minor">
-            <a:schemeClr val="lt1"/>
-          </a:fontRef>
-        </p:style>
-        <p:txBody>
-          <a:bodyPr rtlCol="0" anchor="ctr" wrap="square"/>
-          <a:lstStyle/>
-          <a:p>
-            <a:pPr algn="ctr">
-              <a:defRPr sz="1200" b="1">
-                <a:solidFill>
-                  <a:srgbClr val="FFFFFF"/>
-                </a:solidFill>
-                <a:latin typeface="Segoe UI"/>
-              </a:defRPr>
-            </a:pPr>
-            <a:r>
-              <a:t>5. DUAL RETRIEVAL</a:t>
-            </a:r>
-          </a:p>
-          <a:p>
-            <a:pPr algn="ctr">
-              <a:spcBef>
-                <a:spcPts val="300"/>
-              </a:spcBef>
-              <a:defRPr sz="950">
-                <a:solidFill>
-                  <a:srgbClr val="AAAAAA"/>
-                </a:solidFill>
-                <a:latin typeface="Segoe UI"/>
-              </a:defRPr>
-            </a:pPr>
-            <a:r>
-              <a:t>BM25 Lexical (k1=1.5, b=0.75)</a:t>
-            </a:r>
-            <a:br/>
-            <a:r>
-              <a:t>BGE-Small Dense Embeddings</a:t>
-            </a:r>
-          </a:p>
-        </p:txBody>
-      </p:sp>
-      <p:sp>
-        <p:nvSpPr>
-          <p:cNvPr id="13" name="Right Arrow 12"/>
-          <p:cNvSpPr/>
-          <p:nvPr/>
-        </p:nvSpPr>
-        <p:spPr>
-          <a:xfrm>
-            <a:off x="3200400" y="3474720"/>
-            <a:ext cx="365760" cy="228600"/>
-          </a:xfrm>
-          <a:prstGeom prst="rightArrow">
-            <a:avLst/>
-          </a:prstGeom>
-          <a:solidFill>
-            <a:srgbClr val="787878"/>
-          </a:solidFill>
-          <a:ln>
-            <a:solidFill>
-              <a:srgbClr val="787878"/>
-            </a:solidFill>
-          </a:ln>
-        </p:spPr>
-        <p:style>
-          <a:lnRef idx="1">
-            <a:schemeClr val="accent1"/>
-          </a:lnRef>
-          <a:fillRef idx="3">
-            <a:schemeClr val="accent1"/>
-          </a:fillRef>
-          <a:effectRef idx="2">
-            <a:schemeClr val="accent1"/>
-          </a:effectRef>
-          <a:fontRef idx="minor">
-            <a:schemeClr val="lt1"/>
-          </a:fontRef>
-        </p:style>
-        <p:txBody>
-          <a:bodyPr rtlCol="0" anchor="ctr"/>
-          <a:lstStyle/>
-          <a:p>
-            <a:pPr algn="ctr"/>
-          </a:p>
-        </p:txBody>
-      </p:sp>
-      <p:sp>
-        <p:nvSpPr>
-          <p:cNvPr id="14" name="Rounded Rectangle 13"/>
-          <p:cNvSpPr/>
-          <p:nvPr/>
-        </p:nvSpPr>
-        <p:spPr>
-          <a:xfrm>
-            <a:off x="3657600" y="3108960"/>
-            <a:ext cx="2377440" cy="1005840"/>
-          </a:xfrm>
-          <a:prstGeom prst="roundRect">
-            <a:avLst/>
-          </a:prstGeom>
-          <a:solidFill>
-            <a:srgbClr val="1C1C1C"/>
-          </a:solidFill>
-          <a:ln w="15240">
-            <a:solidFill>
-              <a:srgbClr val="373737"/>
-            </a:solidFill>
-          </a:ln>
-        </p:spPr>
-        <p:style>
-          <a:lnRef idx="1">
-            <a:schemeClr val="accent1"/>
-          </a:lnRef>
-          <a:fillRef idx="3">
-            <a:schemeClr val="accent1"/>
-          </a:fillRef>
-          <a:effectRef idx="2">
-            <a:schemeClr val="accent1"/>
-          </a:effectRef>
-          <a:fontRef idx="minor">
-            <a:schemeClr val="lt1"/>
-          </a:fontRef>
-        </p:style>
-        <p:txBody>
-          <a:bodyPr rtlCol="0" anchor="ctr" wrap="square"/>
-          <a:lstStyle/>
-          <a:p>
-            <a:pPr algn="ctr">
-              <a:defRPr sz="1200" b="1">
-                <a:solidFill>
-                  <a:srgbClr val="FFFFFF"/>
-                </a:solidFill>
-                <a:latin typeface="Segoe UI"/>
-              </a:defRPr>
-            </a:pPr>
-            <a:r>
-              <a:t>6. RECIPROCAL RANK FUSION</a:t>
-            </a:r>
-          </a:p>
-          <a:p>
-            <a:pPr algn="ctr">
-              <a:spcBef>
-                <a:spcPts val="300"/>
-              </a:spcBef>
-              <a:defRPr sz="950">
-                <a:solidFill>
-                  <a:srgbClr val="AAAAAA"/>
-                </a:solidFill>
-                <a:latin typeface="Segoe UI"/>
-              </a:defRPr>
-            </a:pPr>
-            <a:r>
-              <a:t>RRF Formula: Score = 1/(k+rank)</a:t>
-            </a:r>
-            <a:br/>
-            <a:r>
-              <a:t>Score Normalization Free</a:t>
-            </a:r>
-          </a:p>
-        </p:txBody>
-      </p:sp>
-      <p:sp>
-        <p:nvSpPr>
-          <p:cNvPr id="15" name="Right Arrow 14"/>
-          <p:cNvSpPr/>
-          <p:nvPr/>
-        </p:nvSpPr>
-        <p:spPr>
-          <a:xfrm>
-            <a:off x="6126480" y="3474720"/>
-            <a:ext cx="365760" cy="228600"/>
-          </a:xfrm>
-          <a:prstGeom prst="rightArrow">
-            <a:avLst/>
-          </a:prstGeom>
-          <a:solidFill>
-            <a:srgbClr val="787878"/>
-          </a:solidFill>
-          <a:ln>
-            <a:solidFill>
-              <a:srgbClr val="787878"/>
-            </a:solidFill>
-          </a:ln>
-        </p:spPr>
-        <p:style>
-          <a:lnRef idx="1">
-            <a:schemeClr val="accent1"/>
-          </a:lnRef>
-          <a:fillRef idx="3">
-            <a:schemeClr val="accent1"/>
-          </a:fillRef>
-          <a:effectRef idx="2">
-            <a:schemeClr val="accent1"/>
-          </a:effectRef>
-          <a:fontRef idx="minor">
-            <a:schemeClr val="lt1"/>
-          </a:fontRef>
-        </p:style>
-        <p:txBody>
-          <a:bodyPr rtlCol="0" anchor="ctr"/>
-          <a:lstStyle/>
-          <a:p>
-            <a:pPr algn="ctr"/>
-          </a:p>
-        </p:txBody>
-      </p:sp>
-      <p:sp>
-        <p:nvSpPr>
-          <p:cNvPr id="16" name="Rounded Rectangle 15"/>
-          <p:cNvSpPr/>
-          <p:nvPr/>
-        </p:nvSpPr>
-        <p:spPr>
-          <a:xfrm>
-            <a:off x="6583680" y="3108960"/>
-            <a:ext cx="2377440" cy="1005840"/>
-          </a:xfrm>
-          <a:prstGeom prst="roundRect">
-            <a:avLst/>
-          </a:prstGeom>
-          <a:solidFill>
-            <a:srgbClr val="1C1C1C"/>
-          </a:solidFill>
-          <a:ln w="15240">
-            <a:solidFill>
-              <a:srgbClr val="373737"/>
-            </a:solidFill>
-          </a:ln>
-        </p:spPr>
-        <p:style>
-          <a:lnRef idx="1">
-            <a:schemeClr val="accent1"/>
-          </a:lnRef>
-          <a:fillRef idx="3">
-            <a:schemeClr val="accent1"/>
-          </a:fillRef>
-          <a:effectRef idx="2">
-            <a:schemeClr val="accent1"/>
-          </a:effectRef>
-          <a:fontRef idx="minor">
-            <a:schemeClr val="lt1"/>
-          </a:fontRef>
-        </p:style>
-        <p:txBody>
-          <a:bodyPr rtlCol="0" anchor="ctr" wrap="square"/>
-          <a:lstStyle/>
-          <a:p>
-            <a:pPr algn="ctr">
-              <a:defRPr sz="1200" b="1">
-                <a:solidFill>
-                  <a:srgbClr val="FFFFFF"/>
-                </a:solidFill>
-                <a:latin typeface="Segoe UI"/>
-              </a:defRPr>
-            </a:pPr>
-            <a:r>
-              <a:t>7. BGE CROSS-ENCODER</a:t>
-            </a:r>
-          </a:p>
-          <a:p>
-            <a:pPr algn="ctr">
-              <a:spcBef>
-                <a:spcPts val="300"/>
-              </a:spcBef>
-              <a:defRPr sz="950">
-                <a:solidFill>
-                  <a:srgbClr val="AAAAAA"/>
-                </a:solidFill>
-                <a:latin typeface="Segoe UI"/>
-              </a:defRPr>
-            </a:pPr>
-            <a:r>
-              <a:t>Pairwise Transformer Reranker</a:t>
-            </a:r>
-            <a:br/>
-            <a:r>
-              <a:t>ms-marco-MiniLM / BGE Base</a:t>
-            </a:r>
-          </a:p>
-        </p:txBody>
-      </p:sp>
-      <p:sp>
-        <p:nvSpPr>
-          <p:cNvPr id="17" name="Right Arrow 16"/>
-          <p:cNvSpPr/>
-          <p:nvPr/>
-        </p:nvSpPr>
-        <p:spPr>
-          <a:xfrm>
-            <a:off x="9052560" y="3474720"/>
-            <a:ext cx="365760" cy="228600"/>
-          </a:xfrm>
-          <a:prstGeom prst="rightArrow">
-            <a:avLst/>
-          </a:prstGeom>
-          <a:solidFill>
-            <a:srgbClr val="787878"/>
-          </a:solidFill>
-          <a:ln>
-            <a:solidFill>
-              <a:srgbClr val="787878"/>
-            </a:solidFill>
-          </a:ln>
-        </p:spPr>
-        <p:style>
-          <a:lnRef idx="1">
-            <a:schemeClr val="accent1"/>
-          </a:lnRef>
-          <a:fillRef idx="3">
-            <a:schemeClr val="accent1"/>
-          </a:fillRef>
-          <a:effectRef idx="2">
-            <a:schemeClr val="accent1"/>
-          </a:effectRef>
-          <a:fontRef idx="minor">
-            <a:schemeClr val="lt1"/>
-          </a:fontRef>
-        </p:style>
-        <p:txBody>
-          <a:bodyPr rtlCol="0" anchor="ctr"/>
-          <a:lstStyle/>
-          <a:p>
-            <a:pPr algn="ctr"/>
-          </a:p>
-        </p:txBody>
-      </p:sp>
-      <p:sp>
-        <p:nvSpPr>
-          <p:cNvPr id="18" name="Rounded Rectangle 17"/>
-          <p:cNvSpPr/>
-          <p:nvPr/>
-        </p:nvSpPr>
-        <p:spPr>
-          <a:xfrm>
-            <a:off x="9509760" y="3108960"/>
-            <a:ext cx="1920240" cy="1005840"/>
-          </a:xfrm>
-          <a:prstGeom prst="roundRect">
-            <a:avLst/>
-          </a:prstGeom>
-          <a:solidFill>
-            <a:srgbClr val="1C1C1C"/>
-          </a:solidFill>
-          <a:ln w="15240">
-            <a:solidFill>
-              <a:srgbClr val="373737"/>
-            </a:solidFill>
-          </a:ln>
-        </p:spPr>
-        <p:style>
-          <a:lnRef idx="1">
-            <a:schemeClr val="accent1"/>
-          </a:lnRef>
-          <a:fillRef idx="3">
-            <a:schemeClr val="accent1"/>
-          </a:fillRef>
-          <a:effectRef idx="2">
-            <a:schemeClr val="accent1"/>
-          </a:effectRef>
-          <a:fontRef idx="minor">
-            <a:schemeClr val="lt1"/>
-          </a:fontRef>
-        </p:style>
-        <p:txBody>
-          <a:bodyPr rtlCol="0" anchor="ctr" wrap="square"/>
-          <a:lstStyle/>
-          <a:p>
-            <a:pPr algn="ctr">
-              <a:defRPr sz="1200" b="1">
-                <a:solidFill>
-                  <a:srgbClr val="FFFFFF"/>
-                </a:solidFill>
-                <a:latin typeface="Segoe UI"/>
-              </a:defRPr>
-            </a:pPr>
-            <a:r>
-              <a:t>8. EVIDENCE MAPPING</a:t>
-            </a:r>
-          </a:p>
-          <a:p>
-            <a:pPr algn="ctr">
-              <a:spcBef>
-                <a:spcPts val="300"/>
-              </a:spcBef>
-              <a:defRPr sz="950">
-                <a:solidFill>
-                  <a:srgbClr val="AAAAAA"/>
-                </a:solidFill>
-                <a:latin typeface="Segoe UI"/>
-              </a:defRPr>
-            </a:pPr>
-            <a:r>
-              <a:t>Direct / Partial / Context</a:t>
-            </a:r>
-            <a:br/>
-            <a:r>
-              <a:t>Prior-Art Claim Overlap</a:t>
-            </a:r>
-          </a:p>
-        </p:txBody>
-      </p:sp>
-      <p:sp>
-        <p:nvSpPr>
-          <p:cNvPr id="19" name="Rounded Rectangle 18"/>
-          <p:cNvSpPr/>
-          <p:nvPr/>
-        </p:nvSpPr>
-        <p:spPr>
-          <a:xfrm>
-            <a:off x="731520" y="4572000"/>
-            <a:ext cx="2560320" cy="1005840"/>
-          </a:xfrm>
-          <a:prstGeom prst="roundRect">
-            <a:avLst/>
-          </a:prstGeom>
-          <a:solidFill>
-            <a:srgbClr val="1C1C1C"/>
-          </a:solidFill>
-          <a:ln w="15240">
-            <a:solidFill>
-              <a:srgbClr val="373737"/>
-            </a:solidFill>
-          </a:ln>
-        </p:spPr>
-        <p:style>
-          <a:lnRef idx="1">
-            <a:schemeClr val="accent1"/>
-          </a:lnRef>
-          <a:fillRef idx="3">
-            <a:schemeClr val="accent1"/>
-          </a:fillRef>
-          <a:effectRef idx="2">
-            <a:schemeClr val="accent1"/>
-          </a:effectRef>
-          <a:fontRef idx="minor">
-            <a:schemeClr val="lt1"/>
-          </a:fontRef>
-        </p:style>
-        <p:txBody>
-          <a:bodyPr rtlCol="0" anchor="ctr" wrap="square"/>
-          <a:lstStyle/>
-          <a:p>
-            <a:pPr algn="ctr">
-              <a:defRPr sz="1200" b="1">
-                <a:solidFill>
-                  <a:srgbClr val="FFFFFF"/>
-                </a:solidFill>
-                <a:latin typeface="Segoe UI"/>
-              </a:defRPr>
-            </a:pPr>
-            <a:r>
-              <a:t>9. DETERMINISTIC EB-PRE</a:t>
-            </a:r>
-          </a:p>
-          <a:p>
-            <a:pPr algn="ctr">
-              <a:spcBef>
-                <a:spcPts val="300"/>
-              </a:spcBef>
-              <a:defRPr sz="950">
-                <a:solidFill>
-                  <a:srgbClr val="AAAAAA"/>
-                </a:solidFill>
-                <a:latin typeface="Segoe UI"/>
-              </a:defRPr>
-            </a:pPr>
-            <a:r>
-              <a:t>6 Metric Dimensions (0-100)</a:t>
-            </a:r>
-            <a:br/>
-            <a:r>
-              <a:t>Novelty, Obviousness, Breadth</a:t>
-            </a:r>
-          </a:p>
-        </p:txBody>
-      </p:sp>
-      <p:sp>
-        <p:nvSpPr>
-          <p:cNvPr id="20" name="Right Arrow 19"/>
-          <p:cNvSpPr/>
-          <p:nvPr/>
-        </p:nvSpPr>
-        <p:spPr>
-          <a:xfrm>
-            <a:off x="3383280" y="4937760"/>
-            <a:ext cx="365760" cy="228600"/>
-          </a:xfrm>
-          <a:prstGeom prst="rightArrow">
-            <a:avLst/>
-          </a:prstGeom>
-          <a:solidFill>
-            <a:srgbClr val="787878"/>
-          </a:solidFill>
-          <a:ln>
-            <a:solidFill>
-              <a:srgbClr val="787878"/>
-            </a:solidFill>
-          </a:ln>
-        </p:spPr>
-        <p:style>
-          <a:lnRef idx="1">
-            <a:schemeClr val="accent1"/>
-          </a:lnRef>
-          <a:fillRef idx="3">
-            <a:schemeClr val="accent1"/>
-          </a:fillRef>
-          <a:effectRef idx="2">
-            <a:schemeClr val="accent1"/>
-          </a:effectRef>
-          <a:fontRef idx="minor">
-            <a:schemeClr val="lt1"/>
-          </a:fontRef>
-        </p:style>
-        <p:txBody>
-          <a:bodyPr rtlCol="0" anchor="ctr"/>
-          <a:lstStyle/>
-          <a:p>
-            <a:pPr algn="ctr"/>
-          </a:p>
-        </p:txBody>
-      </p:sp>
-      <p:sp>
-        <p:nvSpPr>
-          <p:cNvPr id="21" name="Rounded Rectangle 20"/>
-          <p:cNvSpPr/>
-          <p:nvPr/>
-        </p:nvSpPr>
-        <p:spPr>
-          <a:xfrm>
-            <a:off x="3840480" y="4572000"/>
-            <a:ext cx="2560320" cy="1005840"/>
-          </a:xfrm>
-          <a:prstGeom prst="roundRect">
-            <a:avLst/>
-          </a:prstGeom>
-          <a:solidFill>
-            <a:srgbClr val="1C1C1C"/>
-          </a:solidFill>
-          <a:ln w="15240">
-            <a:solidFill>
-              <a:srgbClr val="373737"/>
-            </a:solidFill>
-          </a:ln>
-        </p:spPr>
-        <p:style>
-          <a:lnRef idx="1">
-            <a:schemeClr val="accent1"/>
-          </a:lnRef>
-          <a:fillRef idx="3">
-            <a:schemeClr val="accent1"/>
-          </a:fillRef>
-          <a:effectRef idx="2">
-            <a:schemeClr val="accent1"/>
-          </a:effectRef>
-          <a:fontRef idx="minor">
-            <a:schemeClr val="lt1"/>
-          </a:fontRef>
-        </p:style>
-        <p:txBody>
-          <a:bodyPr rtlCol="0" anchor="ctr" wrap="square"/>
-          <a:lstStyle/>
-          <a:p>
-            <a:pPr algn="ctr">
-              <a:defRPr sz="1200" b="1">
-                <a:solidFill>
-                  <a:srgbClr val="FFFFFF"/>
-                </a:solidFill>
-                <a:latin typeface="Segoe UI"/>
-              </a:defRPr>
-            </a:pPr>
-            <a:r>
-              <a:t>10. GROUNDED EXPLAINER</a:t>
-            </a:r>
-          </a:p>
-          <a:p>
-            <a:pPr algn="ctr">
-              <a:spcBef>
-                <a:spcPts val="300"/>
-              </a:spcBef>
-              <a:defRPr sz="950">
-                <a:solidFill>
-                  <a:srgbClr val="AAAAAA"/>
-                </a:solidFill>
-                <a:latin typeface="Segoe UI"/>
-              </a:defRPr>
-            </a:pPr>
-            <a:r>
-              <a:t>Google Gemini 3.1 Pro</a:t>
-            </a:r>
-            <a:br/>
-            <a:r>
-              <a:t>Deterministic 429 Fallback</a:t>
-            </a:r>
-          </a:p>
-        </p:txBody>
-      </p:sp>
-      <p:sp>
-        <p:nvSpPr>
-          <p:cNvPr id="22" name="Right Arrow 21"/>
-          <p:cNvSpPr/>
-          <p:nvPr/>
-        </p:nvSpPr>
-        <p:spPr>
-          <a:xfrm>
-            <a:off x="6492240" y="4937760"/>
-            <a:ext cx="365760" cy="228600"/>
-          </a:xfrm>
-          <a:prstGeom prst="rightArrow">
-            <a:avLst/>
-          </a:prstGeom>
-          <a:solidFill>
-            <a:srgbClr val="787878"/>
-          </a:solidFill>
-          <a:ln>
-            <a:solidFill>
-              <a:srgbClr val="787878"/>
-            </a:solidFill>
-          </a:ln>
-        </p:spPr>
-        <p:style>
-          <a:lnRef idx="1">
-            <a:schemeClr val="accent1"/>
-          </a:lnRef>
-          <a:fillRef idx="3">
-            <a:schemeClr val="accent1"/>
-          </a:fillRef>
-          <a:effectRef idx="2">
-            <a:schemeClr val="accent1"/>
-          </a:effectRef>
-          <a:fontRef idx="minor">
-            <a:schemeClr val="lt1"/>
-          </a:fontRef>
-        </p:style>
-        <p:txBody>
-          <a:bodyPr rtlCol="0" anchor="ctr"/>
-          <a:lstStyle/>
-          <a:p>
-            <a:pPr algn="ctr"/>
-          </a:p>
-        </p:txBody>
-      </p:sp>
-      <p:sp>
-        <p:nvSpPr>
-          <p:cNvPr id="23" name="Rounded Rectangle 22"/>
-          <p:cNvSpPr/>
-          <p:nvPr/>
-        </p:nvSpPr>
-        <p:spPr>
-          <a:xfrm>
-            <a:off x="6949440" y="4572000"/>
-            <a:ext cx="2377440" cy="1005840"/>
-          </a:xfrm>
-          <a:prstGeom prst="roundRect">
-            <a:avLst/>
-          </a:prstGeom>
-          <a:solidFill>
-            <a:srgbClr val="1C1C1C"/>
-          </a:solidFill>
-          <a:ln w="15240">
-            <a:solidFill>
-              <a:srgbClr val="373737"/>
-            </a:solidFill>
-          </a:ln>
-        </p:spPr>
-        <p:style>
-          <a:lnRef idx="1">
-            <a:schemeClr val="accent1"/>
-          </a:lnRef>
-          <a:fillRef idx="3">
-            <a:schemeClr val="accent1"/>
-          </a:fillRef>
-          <a:effectRef idx="2">
-            <a:schemeClr val="accent1"/>
-          </a:effectRef>
-          <a:fontRef idx="minor">
-            <a:schemeClr val="lt1"/>
-          </a:fontRef>
-        </p:style>
-        <p:txBody>
-          <a:bodyPr rtlCol="0" anchor="ctr" wrap="square"/>
-          <a:lstStyle/>
-          <a:p>
-            <a:pPr algn="ctr">
-              <a:defRPr sz="1200" b="1">
-                <a:solidFill>
-                  <a:srgbClr val="FFFFFF"/>
-                </a:solidFill>
-                <a:latin typeface="Segoe UI"/>
-              </a:defRPr>
-            </a:pPr>
-            <a:r>
-              <a:t>11. DURABLE DATABASE</a:t>
-            </a:r>
-          </a:p>
-          <a:p>
-            <a:pPr algn="ctr">
-              <a:spcBef>
-                <a:spcPts val="300"/>
-              </a:spcBef>
-              <a:defRPr sz="950">
-                <a:solidFill>
-                  <a:srgbClr val="AAAAAA"/>
-                </a:solidFill>
-                <a:latin typeface="Segoe UI"/>
-              </a:defRPr>
-            </a:pPr>
-            <a:r>
-              <a:t>ACID SQLite Store</a:t>
-            </a:r>
-            <a:br/>
-            <a:r>
-              <a:t>Projects, Scores &amp; Mappings</a:t>
-            </a:r>
-          </a:p>
-        </p:txBody>
-      </p:sp>
-      <p:sp>
-        <p:nvSpPr>
-          <p:cNvPr id="24" name="Right Arrow 23"/>
-          <p:cNvSpPr/>
-          <p:nvPr/>
-        </p:nvSpPr>
-        <p:spPr>
-          <a:xfrm>
-            <a:off x="9418320" y="4937760"/>
-            <a:ext cx="365760" cy="228600"/>
-          </a:xfrm>
-          <a:prstGeom prst="rightArrow">
-            <a:avLst/>
-          </a:prstGeom>
-          <a:solidFill>
-            <a:srgbClr val="787878"/>
-          </a:solidFill>
-          <a:ln>
-            <a:solidFill>
-              <a:srgbClr val="787878"/>
-            </a:solidFill>
-          </a:ln>
-        </p:spPr>
-        <p:style>
-          <a:lnRef idx="1">
-            <a:schemeClr val="accent1"/>
-          </a:lnRef>
-          <a:fillRef idx="3">
-            <a:schemeClr val="accent1"/>
-          </a:fillRef>
-          <a:effectRef idx="2">
-            <a:schemeClr val="accent1"/>
-          </a:effectRef>
-          <a:fontRef idx="minor">
-            <a:schemeClr val="lt1"/>
-          </a:fontRef>
-        </p:style>
-        <p:txBody>
-          <a:bodyPr rtlCol="0" anchor="ctr"/>
-          <a:lstStyle/>
-          <a:p>
-            <a:pPr algn="ctr"/>
-          </a:p>
-        </p:txBody>
-      </p:sp>
-      <p:sp>
-        <p:nvSpPr>
-          <p:cNvPr id="25" name="Rounded Rectangle 24"/>
-          <p:cNvSpPr/>
-          <p:nvPr/>
-        </p:nvSpPr>
-        <p:spPr>
-          <a:xfrm>
-            <a:off x="9875520" y="4572000"/>
-            <a:ext cx="1554480" cy="1005840"/>
-          </a:xfrm>
-          <a:prstGeom prst="roundRect">
-            <a:avLst/>
-          </a:prstGeom>
-          <a:solidFill>
-            <a:srgbClr val="1C1C1C"/>
-          </a:solidFill>
-          <a:ln w="15240">
-            <a:solidFill>
-              <a:srgbClr val="373737"/>
-            </a:solidFill>
-          </a:ln>
-        </p:spPr>
-        <p:style>
-          <a:lnRef idx="1">
-            <a:schemeClr val="accent1"/>
-          </a:lnRef>
-          <a:fillRef idx="3">
-            <a:schemeClr val="accent1"/>
-          </a:fillRef>
-          <a:effectRef idx="2">
-            <a:schemeClr val="accent1"/>
-          </a:effectRef>
-          <a:fontRef idx="minor">
-            <a:schemeClr val="lt1"/>
-          </a:fontRef>
-        </p:style>
-        <p:txBody>
-          <a:bodyPr rtlCol="0" anchor="ctr" wrap="square"/>
-          <a:lstStyle/>
-          <a:p>
-            <a:pPr algn="ctr">
-              <a:defRPr sz="1200" b="1">
-                <a:solidFill>
-                  <a:srgbClr val="FFFFFF"/>
-                </a:solidFill>
-                <a:latin typeface="Segoe UI"/>
-              </a:defRPr>
-            </a:pPr>
-            <a:r>
-              <a:t>12. REACT 19 UI</a:t>
-            </a:r>
-          </a:p>
-          <a:p>
-            <a:pPr algn="ctr">
-              <a:spcBef>
-                <a:spcPts val="300"/>
-              </a:spcBef>
-              <a:defRPr sz="950">
-                <a:solidFill>
-                  <a:srgbClr val="AAAAAA"/>
-                </a:solidFill>
-                <a:latin typeface="Segoe UI"/>
-              </a:defRPr>
-            </a:pPr>
-            <a:r>
-              <a:t>Tailwind CSS</a:t>
-            </a:r>
-            <a:br/>
-            <a:r>
-              <a:t>Interactive Matrix</a:t>
-            </a:r>
-          </a:p>
-        </p:txBody>
-      </p:sp>
-      <p:sp>
-        <p:nvSpPr>
-          <p:cNvPr id="26" name="Rectangle 25"/>
-          <p:cNvSpPr/>
-          <p:nvPr/>
-        </p:nvSpPr>
-        <p:spPr>
-          <a:xfrm>
-            <a:off x="731520" y="5852160"/>
-            <a:ext cx="10698480" cy="548640"/>
+      <p:pic>
+        <p:nvPicPr>
+          <p:cNvPr id="6" name="Picture 5" descr="fig_full_architecture_gitdiagram.png"/>
+          <p:cNvPicPr>
+            <a:picLocks noChangeAspect="1"/>
+          </p:cNvPicPr>
+          <p:nvPr/>
+        </p:nvPicPr>
+        <p:blipFill>
+          <a:blip r:embed="rId2"/>
+          <a:stretch>
+            <a:fillRect/>
+          </a:stretch>
+        </p:blipFill>
+        <p:spPr>
+          <a:xfrm>
+            <a:off x="1843887" y="1490472"/>
+            <a:ext cx="8503920" cy="4919472"/>
           </a:xfrm>
           <a:prstGeom prst="rect">
             <a:avLst/>
           </a:prstGeom>
-          <a:solidFill>
-            <a:srgbClr val="141414"/>
-          </a:solidFill>
-          <a:ln w="12700">
-            <a:solidFill>
-              <a:srgbClr val="373737"/>
-            </a:solidFill>
-          </a:ln>
-        </p:spPr>
-        <p:style>
-          <a:lnRef idx="1">
-            <a:schemeClr val="accent1"/>
-          </a:lnRef>
-          <a:fillRef idx="3">
-            <a:schemeClr val="accent1"/>
-          </a:fillRef>
-          <a:effectRef idx="2">
-            <a:schemeClr val="accent1"/>
-          </a:effectRef>
-          <a:fontRef idx="minor">
-            <a:schemeClr val="lt1"/>
-          </a:fontRef>
-        </p:style>
-        <p:txBody>
-          <a:bodyPr rtlCol="0" anchor="ctr"/>
-          <a:lstStyle/>
-          <a:p>
-            <a:pPr algn="ctr">
-              <a:defRPr sz="1050" b="1">
-                <a:solidFill>
-                  <a:srgbClr val="FFFFFF"/>
-                </a:solidFill>
-                <a:latin typeface="Segoe UI"/>
-              </a:defRPr>
-            </a:pPr>
-            <a:r>
-              <a:t>CORE GUARANTEE: Zero hallucination in readiness scores — EB-PRE is 100% deterministic mathematical evaluation; LLM is restricted solely to formatting human-readable summaries.</a:t>
-            </a:r>
-          </a:p>
-        </p:txBody>
-      </p:sp>
+        </p:spPr>
+      </p:pic>
     </p:spTree>
   </p:cSld>
   <p:clrMapOvr>

</xml_diff>

<commit_message>
style(presentation): simplify slide 1 team and guide details to match template
</commit_message>
<xml_diff>
--- a/PatentIQ_Final_Review_Presentation.pptx
+++ b/PatentIQ_Final_Review_Presentation.pptx
@@ -3286,8 +3286,8 @@
         </p:nvSpPr>
         <p:spPr>
           <a:xfrm>
-            <a:off x="1188720" y="3931920"/>
-            <a:ext cx="9784080" cy="1737360"/>
+            <a:off x="1188720" y="3977639"/>
+            <a:ext cx="9784080" cy="475488"/>
           </a:xfrm>
           <a:prstGeom prst="rect">
             <a:avLst/>
@@ -3316,10 +3316,20 @@
           </a:fontRef>
         </p:style>
         <p:txBody>
-          <a:bodyPr rtlCol="0" anchor="ctr"/>
-          <a:lstStyle/>
-          <a:p>
-            <a:pPr algn="ctr"/>
+          <a:bodyPr rtlCol="0" anchor="ctr" wrap="square"/>
+          <a:lstStyle/>
+          <a:p>
+            <a:pPr algn="l">
+              <a:defRPr sz="1300" b="1">
+                <a:solidFill>
+                  <a:srgbClr val="FFFFFF"/>
+                </a:solidFill>
+                <a:latin typeface="Segoe UI"/>
+              </a:defRPr>
+            </a:pPr>
+            <a:r>
+              <a:t>N. Gagan Karthik — 23BDS1100  |  K. Bharath — 23BDS1033  |  P. Srujan — 23BCE1111</a:t>
+            </a:r>
           </a:p>
         </p:txBody>
       </p:sp>
@@ -3331,8 +3341,8 @@
         </p:nvSpPr>
         <p:spPr>
           <a:xfrm>
-            <a:off x="1371600" y="4069080"/>
-            <a:ext cx="4572000" cy="1463040"/>
+            <a:off x="1188720" y="4526280"/>
+            <a:ext cx="9784080" cy="411480"/>
           </a:xfrm>
           <a:prstGeom prst="rect">
             <a:avLst/>
@@ -3346,49 +3356,15 @@
           <a:lstStyle/>
           <a:p>
             <a:pPr>
-              <a:defRPr sz="1000" b="1">
-                <a:solidFill>
-                  <a:srgbClr val="787878"/>
-                </a:solidFill>
-                <a:latin typeface="Segoe UI"/>
-              </a:defRPr>
-            </a:pPr>
-            <a:r>
-              <a:t>CANDIDATE DETAILS</a:t>
-            </a:r>
-          </a:p>
-          <a:p>
-            <a:pPr>
-              <a:defRPr sz="1600" b="1">
-                <a:solidFill>
-                  <a:srgbClr val="FFFFFF"/>
-                </a:solidFill>
-                <a:latin typeface="Segoe UI"/>
-              </a:defRPr>
-            </a:pPr>
-            <a:r>
-              <a:t>N. GAGAN KARTHIK</a:t>
-            </a:r>
-          </a:p>
-          <a:p>
-            <a:pPr>
-              <a:defRPr sz="1200">
-                <a:solidFill>
-                  <a:srgbClr val="AAAAAA"/>
-                </a:solidFill>
-                <a:latin typeface="Segoe UI"/>
-              </a:defRPr>
-            </a:pPr>
-            <a:r>
-              <a:t>Register No: 23BDS1100</a:t>
-            </a:r>
-            <a:br/>
-            <a:r>
-              <a:t>B.Tech. Computer Science and Engineering</a:t>
-            </a:r>
-            <a:br/>
-            <a:r>
-              <a:t>(Specialization in Data Science)</a:t>
+              <a:defRPr sz="1300">
+                <a:solidFill>
+                  <a:srgbClr val="AAAAAA"/>
+                </a:solidFill>
+                <a:latin typeface="Segoe UI"/>
+              </a:defRPr>
+            </a:pPr>
+            <a:r>
+              <a:t>School of Computer Science &amp; Engineering • VIT Chennai</a:t>
             </a:r>
           </a:p>
         </p:txBody>
@@ -3401,8 +3377,8 @@
         </p:nvSpPr>
         <p:spPr>
           <a:xfrm>
-            <a:off x="6217920" y="4069080"/>
-            <a:ext cx="4572000" cy="1463040"/>
+            <a:off x="1188720" y="4983480"/>
+            <a:ext cx="9784080" cy="502920"/>
           </a:xfrm>
           <a:prstGeom prst="rect">
             <a:avLst/>
@@ -3416,19 +3392,6 @@
           <a:lstStyle/>
           <a:p>
             <a:pPr>
-              <a:defRPr sz="1000" b="1">
-                <a:solidFill>
-                  <a:srgbClr val="787878"/>
-                </a:solidFill>
-                <a:latin typeface="Segoe UI"/>
-              </a:defRPr>
-            </a:pPr>
-            <a:r>
-              <a:t>PROJECT SUPERVISOR &amp; GUIDE</a:t>
-            </a:r>
-          </a:p>
-          <a:p>
-            <a:pPr>
               <a:defRPr sz="1600" b="1">
                 <a:solidFill>
                   <a:srgbClr val="FFFFFF"/>
@@ -3437,24 +3400,7 @@
               </a:defRPr>
             </a:pPr>
             <a:r>
-              <a:t>Dr. VIJAYRAJ J</a:t>
-            </a:r>
-          </a:p>
-          <a:p>
-            <a:pPr>
-              <a:defRPr sz="1200">
-                <a:solidFill>
-                  <a:srgbClr val="AAAAAA"/>
-                </a:solidFill>
-                <a:latin typeface="Segoe UI"/>
-              </a:defRPr>
-            </a:pPr>
-            <a:r>
-              <a:t>Department of Data Science</a:t>
-            </a:r>
-            <a:br/>
-            <a:r>
-              <a:t>School of Computer Science and Engineering (SCOPE)</a:t>
+              <a:t>Guide : Dr. Vijayaraj J</a:t>
             </a:r>
           </a:p>
         </p:txBody>

</xml_diff>